<commit_message>
Update poster with XGBoost architecture diagram
Added two-stage prediction pipeline visualization for the poster Method section. Includes helper scripts: _fix_round.py (adjusts corner radius consistency across cards) and _make_arch_xgboost.py (generates architecture diagram). Updated poster PDF and PPTX files with refined visuals.
</commit_message>
<xml_diff>
--- a/poster/Predictive_Modeling_Root-Zone_Poster_Final.pptx
+++ b/poster/Predictive_Modeling_Root-Zone_Poster_Final.pptx
@@ -257,7 +257,7 @@
             <a:fld id="{0158C5BC-9A70-462C-B28D-9600239EAC64}" type="datetimeFigureOut">
               <a:rPr lang="en-US" smtClean="0"/>
               <a:pPr/>
-              <a:t>6/24/2026</a:t>
+              <a:t>6/28/2026</a:t>
             </a:fld>
             <a:endParaRPr lang="en-US"/>
           </a:p>
@@ -424,7 +424,7 @@
             <a:fld id="{E6CC2317-6751-4CD4-9995-8782DD78E936}" type="datetimeFigureOut">
               <a:rPr lang="en-US" smtClean="0"/>
               <a:pPr/>
-              <a:t>6/24/2026</a:t>
+              <a:t>6/28/2026</a:t>
             </a:fld>
             <a:endParaRPr lang="en-US" dirty="0"/>
           </a:p>
@@ -12014,17 +12014,11 @@
               <a:lnSpc>
                 <a:spcPct val="105000"/>
               </a:lnSpc>
-              <a:spcBef>
-                <a:spcPts val="0"/>
-              </a:spcBef>
-              <a:spcAft>
-                <a:spcPts val="0"/>
-              </a:spcAft>
             </a:pPr>
             <a:r>
               <a:rPr sz="3600" b="1" dirty="0">
                 <a:solidFill>
-                  <a:srgbClr val="2E3517"/>
+                  <a:srgbClr val="3D4A1F"/>
                 </a:solidFill>
                 <a:latin typeface="Calibri"/>
               </a:rPr>
@@ -12033,7 +12027,7 @@
             <a:r>
               <a:rPr lang="en-US" sz="3600" b="1" dirty="0">
                 <a:solidFill>
-                  <a:srgbClr val="2E3517"/>
+                  <a:srgbClr val="3D4A1F"/>
                 </a:solidFill>
                 <a:latin typeface="Calibri"/>
               </a:rPr>
@@ -12042,7 +12036,7 @@
             <a:r>
               <a:rPr sz="3600" b="1" dirty="0">
                 <a:solidFill>
-                  <a:srgbClr val="2E3517"/>
+                  <a:srgbClr val="3D4A1F"/>
                 </a:solidFill>
                 <a:latin typeface="Calibri"/>
               </a:rPr>
@@ -12111,7 +12105,7 @@
           </a:xfrm>
           <a:prstGeom prst="roundRect">
             <a:avLst>
-              <a:gd name="adj" fmla="val 3500"/>
+              <a:gd name="adj" fmla="val 5663"/>
             </a:avLst>
           </a:prstGeom>
           <a:solidFill>
@@ -12396,7 +12390,7 @@
           </a:xfrm>
           <a:prstGeom prst="roundRect">
             <a:avLst>
-              <a:gd name="adj" fmla="val 3500"/>
+              <a:gd name="adj" fmla="val 5663"/>
             </a:avLst>
           </a:prstGeom>
           <a:solidFill>
@@ -12663,7 +12657,7 @@
           </a:xfrm>
           <a:prstGeom prst="roundRect">
             <a:avLst>
-              <a:gd name="adj" fmla="val 3500"/>
+              <a:gd name="adj" fmla="val 4110"/>
             </a:avLst>
           </a:prstGeom>
           <a:solidFill>
@@ -13168,7 +13162,7 @@
                   </a:schemeClr>
                 </a:solidFill>
               </a:rPr>
-              <a:t>Unified 10-minute master dataset, May 29-Sep 21, 2025:</a:t>
+              <a:t>Unified 10-minute master dataset, May 29 – Sep 21, 2025:</a:t>
             </a:r>
             <a:br>
               <a:rPr lang="en-US" sz="2400" dirty="0">
@@ -13205,21 +13199,7 @@
                   </a:schemeClr>
                 </a:solidFill>
               </a:rPr>
-              <a:t>External weather &amp; solar radiation </a:t>
-            </a:r>
-            <a:r>
-              <a:rPr lang="he-IL" sz="2400" b="1" dirty="0">
-                <a:solidFill>
-                  <a:schemeClr val="tx2">
-                    <a:lumMod val="75000"/>
-                  </a:schemeClr>
-                </a:solidFill>
-              </a:rPr>
-              <a:t> </a:t>
-            </a:r>
-            <a:r>
-              <a:rPr lang="he-IL" sz="2400" dirty="0"/>
-              <a:t>—</a:t>
+              <a:t>External weather &amp; solar radiation — </a:t>
             </a:r>
             <a:r>
               <a:rPr lang="en-US" sz="2400" dirty="0">
@@ -13476,7 +13456,7 @@
           </a:xfrm>
           <a:prstGeom prst="roundRect">
             <a:avLst>
-              <a:gd name="adj" fmla="val 3500"/>
+              <a:gd name="adj" fmla="val 3000"/>
             </a:avLst>
           </a:prstGeom>
           <a:solidFill>
@@ -13865,7 +13845,7 @@
           </a:xfrm>
           <a:prstGeom prst="roundRect">
             <a:avLst>
-              <a:gd name="adj" fmla="val 3500"/>
+              <a:gd name="adj" fmla="val 2069"/>
             </a:avLst>
           </a:prstGeom>
           <a:solidFill>
@@ -14133,7 +14113,7 @@
                   <a:srgbClr val="2E3517"/>
                 </a:solidFill>
               </a:rPr>
-              <a:t>Main nonlinear model for tabular greenhouse data.</a:t>
+              <a:t>Main model for nonlinear tabular greenhouse data.</a:t>
             </a:r>
           </a:p>
           <a:p>
@@ -14148,7 +14128,7 @@
                   <a:srgbClr val="2E3517"/>
                 </a:solidFill>
               </a:rPr>
-              <a:t>Captures interactions between climate, irrigation, fertigation, crop state and baseline pH/EC.</a:t>
+              <a:t>Captures interactions between climate, irrigation, fertigation, crop state, and baseline pH/EC.</a:t>
             </a:r>
             <a:endParaRPr lang="en-US" sz="2400" b="0" dirty="0">
               <a:solidFill>
@@ -14236,22 +14216,22 @@
                   <a:srgbClr val="2E3517"/>
                 </a:solidFill>
               </a:rPr>
-              <a:t>Robust companion model for sharp pH/EC shifts.</a:t>
+              <a:t>Robust companion model for sharp pH/EC shifts. </a:t>
             </a:r>
-          </a:p>
-          <a:p>
-            <a:pPr>
-              <a:lnSpc>
-                <a:spcPct val="104000"/>
-              </a:lnSpc>
-            </a:pPr>
+            <a:br>
+              <a:rPr lang="en-US" sz="2400" dirty="0">
+                <a:solidFill>
+                  <a:srgbClr val="2E3517"/>
+                </a:solidFill>
+              </a:rPr>
+            </a:br>
             <a:r>
               <a:rPr lang="en-US" sz="2400" dirty="0">
                 <a:solidFill>
                   <a:srgbClr val="2E3517"/>
                 </a:solidFill>
               </a:rPr>
-              <a:t>Reduces sensitivity to outliers caused by acid injection, fertigation and salinity events.</a:t>
+              <a:t>Reduces sensitivity to extreme intervals linked to acid injection, fertigation, or salinity changes.</a:t>
             </a:r>
             <a:endParaRPr lang="en-US" sz="2400" b="0" dirty="0">
               <a:solidFill>
@@ -14275,7 +14255,7 @@
           </a:xfrm>
           <a:prstGeom prst="roundRect">
             <a:avLst>
-              <a:gd name="adj" fmla="val 3500"/>
+              <a:gd name="adj" fmla="val 2752"/>
             </a:avLst>
           </a:prstGeom>
           <a:solidFill>
@@ -14572,7 +14552,7 @@
           </a:xfrm>
           <a:prstGeom prst="roundRect">
             <a:avLst>
-              <a:gd name="adj" fmla="val 3500"/>
+              <a:gd name="adj" fmla="val 2667"/>
             </a:avLst>
           </a:prstGeom>
           <a:solidFill>
@@ -15348,12 +15328,12 @@
         </p:nvSpPr>
         <p:spPr>
           <a:xfrm>
-            <a:off x="12907292" y="27655802"/>
+            <a:off x="12907292" y="27694704"/>
             <a:ext cx="11664000" cy="3717539"/>
           </a:xfrm>
           <a:prstGeom prst="roundRect">
             <a:avLst>
-              <a:gd name="adj" fmla="val 3500"/>
+              <a:gd name="adj" fmla="val 5810"/>
             </a:avLst>
           </a:prstGeom>
           <a:solidFill>
@@ -15397,7 +15377,7 @@
         </p:nvSpPr>
         <p:spPr>
           <a:xfrm>
-            <a:off x="13177292" y="27907803"/>
+            <a:off x="13177292" y="27946705"/>
             <a:ext cx="612000" cy="612000"/>
           </a:xfrm>
           <a:prstGeom prst="roundRect">
@@ -15462,7 +15442,7 @@
         </p:nvSpPr>
         <p:spPr>
           <a:xfrm>
-            <a:off x="13933293" y="27898653"/>
+            <a:off x="13933293" y="27937555"/>
             <a:ext cx="10440000" cy="626701"/>
           </a:xfrm>
           <a:prstGeom prst="rect">
@@ -15507,7 +15487,7 @@
         </p:nvSpPr>
         <p:spPr>
           <a:xfrm>
-            <a:off x="13195292" y="28599003"/>
+            <a:off x="13195292" y="28637905"/>
             <a:ext cx="11087999" cy="16200"/>
           </a:xfrm>
           <a:prstGeom prst="rect">
@@ -15552,7 +15532,7 @@
         </p:nvSpPr>
         <p:spPr>
           <a:xfrm>
-            <a:off x="13213293" y="28731894"/>
+            <a:off x="13213293" y="28770796"/>
             <a:ext cx="11286000" cy="2559089"/>
           </a:xfrm>
           <a:prstGeom prst="rect">
@@ -15592,7 +15572,7 @@
                   </a:schemeClr>
                 </a:solidFill>
               </a:rPr>
-              <a:t>Prediction value </a:t>
+              <a:t>Prediction value →</a:t>
             </a:r>
             <a:r>
               <a:rPr lang="en-US" sz="2400" dirty="0">
@@ -15602,7 +15582,7 @@
                   </a:schemeClr>
                 </a:solidFill>
               </a:rPr>
-              <a:t>→ The model improved over the last-measurement baseline (+62% pH, +35% EC) and supports earlier pH/EC drift detection.</a:t>
+              <a:t> The model improved over the last-measurement baseline (+62% pH, +35% EC) and supports earlier pH/EC drift detection.</a:t>
             </a:r>
           </a:p>
           <a:p>
@@ -15632,7 +15612,21 @@
                   </a:schemeClr>
                 </a:solidFill>
               </a:rPr>
-              <a:t>Decision-support platform </a:t>
+              <a:t>Decision-support </a:t>
+            </a:r>
+            <a:r>
+              <a:rPr lang="he-IL" sz="2400" b="1" dirty="0"/>
+              <a:t>prototype</a:t>
+            </a:r>
+            <a:r>
+              <a:rPr lang="en-US" sz="2400" b="1" dirty="0">
+                <a:solidFill>
+                  <a:schemeClr val="tx2">
+                    <a:lumMod val="75000"/>
+                  </a:schemeClr>
+                </a:solidFill>
+              </a:rPr>
+              <a:t> →</a:t>
             </a:r>
             <a:r>
               <a:rPr lang="en-US" sz="2400" dirty="0">
@@ -15642,7 +15636,7 @@
                   </a:schemeClr>
                 </a:solidFill>
               </a:rPr>
-              <a:t>→ built a user platform where growers can test planned irrigation/fertigation actions before applying them.</a:t>
+              <a:t> built a user platform where growers can test planned irrigation/fertigation actions before applying them.</a:t>
             </a:r>
           </a:p>
           <a:p>
@@ -15672,7 +15666,7 @@
                   </a:schemeClr>
                 </a:solidFill>
               </a:rPr>
-              <a:t>Soft-sensor feasibility </a:t>
+              <a:t>Soft-sensor feasibility →</a:t>
             </a:r>
             <a:r>
               <a:rPr lang="en-US" sz="2400" dirty="0">
@@ -15682,7 +15676,7 @@
                   </a:schemeClr>
                 </a:solidFill>
               </a:rPr>
-              <a:t>→ sparse samples can support useful forecasts when combined with dense operational data.</a:t>
+              <a:t> sparse samples can support useful forecasts when combined with dense operational data.</a:t>
             </a:r>
             <a:endParaRPr sz="2400" dirty="0">
               <a:solidFill>
@@ -15703,12 +15697,12 @@
         </p:nvSpPr>
         <p:spPr>
           <a:xfrm>
-            <a:off x="12907292" y="31589340"/>
+            <a:off x="12907292" y="31661340"/>
             <a:ext cx="11664000" cy="3662463"/>
           </a:xfrm>
           <a:prstGeom prst="roundRect">
             <a:avLst>
-              <a:gd name="adj" fmla="val 3500"/>
+              <a:gd name="adj" fmla="val 5898"/>
             </a:avLst>
           </a:prstGeom>
           <a:solidFill>
@@ -15752,7 +15746,7 @@
         </p:nvSpPr>
         <p:spPr>
           <a:xfrm>
-            <a:off x="13177292" y="31923051"/>
+            <a:off x="13177292" y="31995051"/>
             <a:ext cx="612000" cy="612000"/>
           </a:xfrm>
           <a:prstGeom prst="roundRect">
@@ -15817,7 +15811,7 @@
         </p:nvSpPr>
         <p:spPr>
           <a:xfrm>
-            <a:off x="13933293" y="31913901"/>
+            <a:off x="13933293" y="31985901"/>
             <a:ext cx="10440000" cy="626701"/>
           </a:xfrm>
           <a:prstGeom prst="rect">
@@ -15862,7 +15856,7 @@
         </p:nvSpPr>
         <p:spPr>
           <a:xfrm>
-            <a:off x="13195292" y="32661143"/>
+            <a:off x="13195292" y="32733143"/>
             <a:ext cx="11087999" cy="16200"/>
           </a:xfrm>
           <a:prstGeom prst="rect">
@@ -15907,7 +15901,7 @@
         </p:nvSpPr>
         <p:spPr>
           <a:xfrm>
-            <a:off x="13181942" y="32811275"/>
+            <a:off x="13181942" y="32883275"/>
             <a:ext cx="11105999" cy="2167572"/>
           </a:xfrm>
           <a:prstGeom prst="rect">
@@ -15921,13 +15915,10 @@
           </a:bodyPr>
           <a:lstStyle/>
           <a:p>
-            <a:pPr algn="l">
+            <a:pPr>
               <a:lnSpc>
                 <a:spcPct val="106000"/>
               </a:lnSpc>
-              <a:spcBef>
-                <a:spcPts val="0"/>
-              </a:spcBef>
               <a:spcAft>
                 <a:spcPts val="300"/>
               </a:spcAft>
@@ -15941,10 +15932,10 @@
                 </a:solidFill>
                 <a:latin typeface="Calibri"/>
               </a:rPr>
-              <a:t>▪  </a:t>
+              <a:t>▪ Sparse EC/pH labels → </a:t>
             </a:r>
             <a:r>
-              <a:rPr lang="da-DK" sz="2400" b="1" dirty="0">
+              <a:rPr lang="en-US" sz="2400" dirty="0">
                 <a:solidFill>
                   <a:schemeClr val="tx2">
                     <a:lumMod val="75000"/>
@@ -15952,10 +15943,10 @@
                 </a:solidFill>
                 <a:latin typeface="Calibri"/>
               </a:rPr>
-              <a:t>Sparse labels </a:t>
+              <a:t>modeled </a:t>
             </a:r>
             <a:r>
-              <a:rPr lang="da-DK" sz="2400" b="0" dirty="0">
+              <a:rPr lang="el-GR" sz="2400" dirty="0">
                 <a:solidFill>
                   <a:schemeClr val="tx2">
                     <a:lumMod val="75000"/>
@@ -15963,10 +15954,20 @@
                 </a:solidFill>
                 <a:latin typeface="Calibri"/>
               </a:rPr>
-              <a:t>→ </a:t>
+              <a:t>Δ</a:t>
             </a:r>
             <a:r>
-              <a:rPr lang="en-US" sz="2400" b="0" dirty="0">
+              <a:rPr lang="en-US" sz="2400" dirty="0">
+                <a:solidFill>
+                  <a:schemeClr val="tx2">
+                    <a:lumMod val="75000"/>
+                  </a:schemeClr>
+                </a:solidFill>
+              </a:rPr>
+              <a:t>pH</a:t>
+            </a:r>
+            <a:r>
+              <a:rPr lang="en-US" sz="2400" dirty="0">
                 <a:solidFill>
                   <a:schemeClr val="tx2">
                     <a:lumMod val="75000"/>
@@ -15974,7 +15975,29 @@
                 </a:solidFill>
                 <a:latin typeface="Calibri"/>
               </a:rPr>
-              <a:t>modeled measured t₀–t₁ changes using accumulated inputs</a:t>
+              <a:t>/</a:t>
+            </a:r>
+            <a:r>
+              <a:rPr lang="el-GR" sz="2400" dirty="0">
+                <a:solidFill>
+                  <a:schemeClr val="tx2">
+                    <a:lumMod val="75000"/>
+                  </a:schemeClr>
+                </a:solidFill>
+                <a:latin typeface="Calibri"/>
+              </a:rPr>
+              <a:t>Δ</a:t>
+            </a:r>
+            <a:r>
+              <a:rPr lang="en-US" sz="2400" dirty="0">
+                <a:solidFill>
+                  <a:schemeClr val="tx2">
+                    <a:lumMod val="75000"/>
+                  </a:schemeClr>
+                </a:solidFill>
+                <a:latin typeface="Calibri"/>
+              </a:rPr>
+              <a:t>EC between measured samples</a:t>
             </a:r>
           </a:p>
           <a:p>
@@ -15998,10 +16021,10 @@
                 </a:solidFill>
                 <a:latin typeface="Calibri"/>
               </a:rPr>
-              <a:t>▪  Missing climate inputs </a:t>
+              <a:t>▪ Missing climate data → </a:t>
             </a:r>
             <a:r>
-              <a:rPr lang="en-US" sz="2400" b="0" dirty="0">
+              <a:rPr lang="en-US" sz="2400" dirty="0">
                 <a:solidFill>
                   <a:schemeClr val="tx2">
                     <a:lumMod val="75000"/>
@@ -16009,16 +16032,8 @@
                 </a:solidFill>
                 <a:latin typeface="Calibri"/>
               </a:rPr>
-              <a:t>→ filled greenhouse gaps with a micro-climate model</a:t>
+              <a:t>filled greenhouse gaps with micro-climate predictions</a:t>
             </a:r>
-            <a:endParaRPr lang="he-IL" sz="2400" b="0" dirty="0">
-              <a:solidFill>
-                <a:schemeClr val="tx2">
-                  <a:lumMod val="75000"/>
-                </a:schemeClr>
-              </a:solidFill>
-              <a:latin typeface="Calibri"/>
-            </a:endParaRPr>
           </a:p>
           <a:p>
             <a:pPr algn="l">
@@ -16033,17 +16048,6 @@
               </a:spcAft>
             </a:pPr>
             <a:r>
-              <a:rPr sz="2400" b="1" dirty="0">
-                <a:solidFill>
-                  <a:schemeClr val="tx2">
-                    <a:lumMod val="75000"/>
-                  </a:schemeClr>
-                </a:solidFill>
-                <a:latin typeface="Calibri"/>
-              </a:rPr>
-              <a:t>▪  </a:t>
-            </a:r>
-            <a:r>
               <a:rPr lang="en-US" sz="2400" b="1" dirty="0">
                 <a:solidFill>
                   <a:schemeClr val="tx2">
@@ -16052,10 +16056,10 @@
                 </a:solidFill>
                 <a:latin typeface="Calibri"/>
               </a:rPr>
-              <a:t>Irregular sampling </a:t>
+              <a:t>▪ Irregular sampling → </a:t>
             </a:r>
             <a:r>
-              <a:rPr lang="en-US" sz="2400" b="0" dirty="0">
+              <a:rPr lang="en-US" sz="2400" dirty="0">
                 <a:solidFill>
                   <a:schemeClr val="tx2">
                     <a:lumMod val="75000"/>
@@ -16063,16 +16067,8 @@
                 </a:solidFill>
                 <a:latin typeface="Calibri"/>
               </a:rPr>
-              <a:t>→ added time-gap and window-based aggregation features</a:t>
+              <a:t>used time-gap and window aggregation features</a:t>
             </a:r>
-            <a:endParaRPr lang="he-IL" sz="2400" b="0" dirty="0">
-              <a:solidFill>
-                <a:schemeClr val="tx2">
-                  <a:lumMod val="75000"/>
-                </a:schemeClr>
-              </a:solidFill>
-              <a:latin typeface="Calibri"/>
-            </a:endParaRPr>
           </a:p>
           <a:p>
             <a:pPr algn="l">
@@ -16087,17 +16083,6 @@
               </a:spcAft>
             </a:pPr>
             <a:r>
-              <a:rPr sz="2400" b="1" dirty="0">
-                <a:solidFill>
-                  <a:schemeClr val="tx2">
-                    <a:lumMod val="75000"/>
-                  </a:schemeClr>
-                </a:solidFill>
-                <a:latin typeface="Calibri"/>
-              </a:rPr>
-              <a:t>▪  </a:t>
-            </a:r>
-            <a:r>
               <a:rPr lang="en-US" sz="2400" b="1" dirty="0">
                 <a:solidFill>
                   <a:schemeClr val="tx2">
@@ -16106,10 +16091,10 @@
                 </a:solidFill>
                 <a:latin typeface="Calibri"/>
               </a:rPr>
-              <a:t>Low EC sensitivity </a:t>
+              <a:t>▪ Small EC changes → </a:t>
             </a:r>
             <a:r>
-              <a:rPr lang="en-US" sz="2400" b="0" dirty="0">
+              <a:rPr lang="en-US" sz="2400" dirty="0">
                 <a:solidFill>
                   <a:schemeClr val="tx2">
                     <a:lumMod val="75000"/>
@@ -16117,16 +16102,8 @@
                 </a:solidFill>
                 <a:latin typeface="Calibri"/>
               </a:rPr>
-              <a:t>→ used log-transformed EC change and absolute-error metrics</a:t>
+              <a:t>applied log-EC change and MAE-based evaluation</a:t>
             </a:r>
-            <a:endParaRPr lang="he-IL" sz="2400" b="0" dirty="0">
-              <a:solidFill>
-                <a:schemeClr val="tx2">
-                  <a:lumMod val="75000"/>
-                </a:schemeClr>
-              </a:solidFill>
-              <a:latin typeface="Calibri"/>
-            </a:endParaRPr>
           </a:p>
           <a:p>
             <a:pPr algn="l">
@@ -16141,17 +16118,6 @@
               </a:spcAft>
             </a:pPr>
             <a:r>
-              <a:rPr sz="2400" b="1" dirty="0">
-                <a:solidFill>
-                  <a:schemeClr val="tx2">
-                    <a:lumMod val="75000"/>
-                  </a:schemeClr>
-                </a:solidFill>
-                <a:latin typeface="Calibri"/>
-              </a:rPr>
-              <a:t>▪  </a:t>
-            </a:r>
-            <a:r>
               <a:rPr lang="en-US" sz="2400" b="1" dirty="0">
                 <a:solidFill>
                   <a:schemeClr val="tx2">
@@ -16160,10 +16126,10 @@
                 </a:solidFill>
                 <a:latin typeface="Calibri"/>
               </a:rPr>
-              <a:t>Limited generalization </a:t>
+              <a:t>▪ Limited generalization → </a:t>
             </a:r>
             <a:r>
-              <a:rPr lang="en-US" sz="2400" b="0" dirty="0">
+              <a:rPr lang="en-US" sz="2400" dirty="0">
                 <a:solidFill>
                   <a:schemeClr val="tx2">
                     <a:lumMod val="75000"/>
@@ -16171,7 +16137,7 @@
                 </a:solidFill>
                 <a:latin typeface="Calibri"/>
               </a:rPr>
-              <a:t>→ validate across more seasons, crops, and conditions</a:t>
+              <a:t>requires testing on more seasons, crops, and greenhouses</a:t>
             </a:r>
           </a:p>
         </p:txBody>
@@ -16237,7 +16203,7 @@
           </a:xfrm>
           <a:prstGeom prst="roundRect">
             <a:avLst>
-              <a:gd name="adj" fmla="val 3500"/>
+              <a:gd name="adj" fmla="val 3000"/>
             </a:avLst>
           </a:prstGeom>
           <a:solidFill>
@@ -16577,36 +16543,6 @@
           </a:p>
         </p:txBody>
       </p:sp>
-      <p:pic>
-        <p:nvPicPr>
-          <p:cNvPr id="48" name="תמונה 47">
-            <a:extLst>
-              <a:ext uri="{FF2B5EF4-FFF2-40B4-BE49-F238E27FC236}">
-                <a16:creationId xmlns:a16="http://schemas.microsoft.com/office/drawing/2014/main" id="{5F5E2702-9552-1F99-49DA-25149C04CE57}"/>
-              </a:ext>
-            </a:extLst>
-          </p:cNvPr>
-          <p:cNvPicPr>
-            <a:picLocks noChangeAspect="1"/>
-          </p:cNvPicPr>
-          <p:nvPr/>
-        </p:nvPicPr>
-        <p:blipFill>
-          <a:blip r:embed="rId8"/>
-          <a:stretch>
-            <a:fillRect/>
-          </a:stretch>
-        </p:blipFill>
-        <p:spPr>
-          <a:xfrm>
-            <a:off x="777149" y="20143502"/>
-            <a:ext cx="11357998" cy="4391759"/>
-          </a:xfrm>
-          <a:prstGeom prst="rect">
-            <a:avLst/>
-          </a:prstGeom>
-        </p:spPr>
-      </p:pic>
       <p:sp>
         <p:nvSpPr>
           <p:cNvPr id="88" name="TextBox 65">
@@ -16679,7 +16615,7 @@
           <p:nvPr/>
         </p:nvPicPr>
         <p:blipFill>
-          <a:blip r:embed="rId9"/>
+          <a:blip r:embed="rId8"/>
           <a:stretch>
             <a:fillRect/>
           </a:stretch>
@@ -16688,6 +16624,42 @@
           <a:xfrm>
             <a:off x="1705892" y="29469395"/>
             <a:ext cx="7812822" cy="5716699"/>
+          </a:xfrm>
+          <a:prstGeom prst="rect">
+            <a:avLst/>
+          </a:prstGeom>
+        </p:spPr>
+      </p:pic>
+      <p:pic>
+        <p:nvPicPr>
+          <p:cNvPr id="46" name="תמונה 45">
+            <a:extLst>
+              <a:ext uri="{FF2B5EF4-FFF2-40B4-BE49-F238E27FC236}">
+                <a16:creationId xmlns:a16="http://schemas.microsoft.com/office/drawing/2014/main" id="{BD81D023-06E1-188A-7257-A7D0126351DD}"/>
+              </a:ext>
+            </a:extLst>
+          </p:cNvPr>
+          <p:cNvPicPr>
+            <a:picLocks noChangeAspect="1"/>
+          </p:cNvPicPr>
+          <p:nvPr/>
+        </p:nvPicPr>
+        <p:blipFill>
+          <a:blip r:embed="rId9" cstate="print">
+            <a:extLst>
+              <a:ext uri="{28A0092B-C50C-407E-A947-70E740481C1C}">
+                <a14:useLocalDpi xmlns:a14="http://schemas.microsoft.com/office/drawing/2010/main" val="0"/>
+              </a:ext>
+            </a:extLst>
+          </a:blip>
+          <a:stretch>
+            <a:fillRect/>
+          </a:stretch>
+        </p:blipFill>
+        <p:spPr>
+          <a:xfrm>
+            <a:off x="818745" y="20051210"/>
+            <a:ext cx="11357994" cy="4391758"/>
           </a:xfrm>
           <a:prstGeom prst="rect">
             <a:avLst/>

</xml_diff>